<commit_message>
0.0.8: sequencer deterministico + abbandono governato (anti-SPOF cognitivo)
- flowState.mjs next: il prossimo passo è funzione dei fatti registrati, non del
  giudizio dell'LLM (prima condizione non soddisfatta = prossimo passo, con azione e
  comando di registrazione). La skill flow diventa un loop next->esegui->registra:
  la DIREZIONE del flusso è codice, l'enforcement resta agli hook (choreography),
  all'orchestratore restano solo lavoro cognitivo e dialogo ai gate.
- Nuovo fatto record-tests-authored (il sequencer ne ha bisogno).
- flowState.mjs abort --reason: abbandono governato con compensazioni (branch da
  eliminare, ticket da annotare, snapshot da ripulire); fase 'aborted' ignorata dagli hook.
- Docs allineate: PROCESS.md (sequencer + abbandono), manuale (razionale SAGA/SPOF in
  3.1, limiti, Appendice), gap analysis (GAP-17 chiuso), README, hooks/README,
  drawio V5, presentazione .pptx. Bump a 0.0.8 (nessuna migrazione: aggiunte additive).
</commit_message>
<xml_diff>
--- a/docs/AI_Dev_Flow_Presentazione_Team.pptx
+++ b/docs/AI_Dev_Flow_Presentazione_Team.pptx
@@ -2134,7 +2134,7 @@
                 <a:ea typeface="Calibri" pitchFamily="34" charset="-122"/>
                 <a:cs typeface="Calibri" pitchFamily="34" charset="-120"/>
               </a:rPr>
-              <a:t>versione 0.0.7</a:t>
+              <a:t>versione 0.0.8</a:t>
             </a:r>
             <a:endParaRPr lang="en-US" sz="1300" dirty="0"/>
           </a:p>
@@ -6946,7 +6946,7 @@
                 <a:ea typeface="Calibri" pitchFamily="34" charset="-122"/>
                 <a:cs typeface="Calibri" pitchFamily="34" charset="-120"/>
               </a:rPr>
-              <a:t>“Lavora su questo ticket: &lt;url&gt;” — l'orchestratore guida le 6 fasi; tu decidi ai 3 gate. Ti interrompi? Si riprende da dov'era.</a:t>
+              <a:t>“Lavora su questo ticket: &lt;url&gt;” — loop deterministico: flowState next → esegui → registra. Tu decidi ai 3 gate; ti interrompi? si riprende da dov'era.</a:t>
             </a:r>
             <a:endParaRPr lang="en-US" sz="1050" dirty="0"/>
           </a:p>

</xml_diff>